<commit_message>
Add slide 4 Thank You conclusion page to AUX Break Management presentation
</commit_message>
<xml_diff>
--- a/AUX_Break_Management.pptx
+++ b/AUX_Break_Management.pptx
@@ -8,6 +8,7 @@
     <p:sldId id="256" r:id="rId2"/>
     <p:sldId id="257" r:id="rId3"/>
     <p:sldId id="258" r:id="rId4"/>
+    <p:sldId id="259" r:id="rId10"/>
   </p:sldIdLst>
   <p:notesMasterIdLst>
     <p:notesMasterId r:id="rId5"/>
@@ -738,6 +739,81 @@
 </p:notes>
 </file>
 
+<file path=ppt/notesSlides/notesSlide4.xml><?xml version="1.0" encoding="utf-8"?>
+<p:notes xmlns:a="http://schemas.openxmlformats.org/drawingml/2006/main" xmlns:p="http://schemas.openxmlformats.org/presentationml/2006/main" xmlns:r="http://schemas.openxmlformats.org/officeDocument/2006/relationships">
+  <p:cSld>
+    <p:spTree>
+      <p:nvGrpSpPr>
+        <p:cNvPr id="1" name=""/>
+        <p:cNvGrpSpPr/>
+        <p:nvPr/>
+      </p:nvGrpSpPr>
+      <p:grpSpPr>
+        <a:xfrm>
+          <a:off x="0" y="0"/>
+          <a:ext cx="0" cy="0"/>
+          <a:chOff x="0" y="0"/>
+          <a:chExt cx="0" cy="0"/>
+        </a:xfrm>
+      </p:grpSpPr>
+      <p:sp>
+        <p:nvSpPr>
+          <p:cNvPr id="2" name="Slide Image Placeholder 1"/>
+          <p:cNvSpPr>
+            <a:spLocks noGrp="1"/>
+          </p:cNvSpPr>
+          <p:nvPr>
+            <p:ph type="sldImg" idx="2"/>
+          </p:nvPr>
+        </p:nvSpPr>
+        <p:spPr/>
+      </p:sp>
+      <p:sp>
+        <p:nvSpPr>
+          <p:cNvPr id="3" name="Notes Placeholder 2"/>
+          <p:cNvSpPr>
+            <a:spLocks noGrp="1"/>
+          </p:cNvSpPr>
+          <p:nvPr>
+            <p:ph type="body" idx="3" sz="quarter"/>
+          </p:nvPr>
+        </p:nvSpPr>
+        <p:spPr/>
+        <p:txBody>
+          <a:bodyPr/>
+          <a:lstStyle/>
+          <a:p>
+            <a:r>
+              <a:t>CLOSING TALK TRACK:</a:t>
+            </a:r>
+          </a:p>
+          <a:p>
+            <a:r>
+              <a:t>Thank you for your time. With ZEL — 'Zero wait to pause, Zero lag to serve' — contact centers eliminate the daily friction of manual break approvals, empower agents with autonomous ACW, and protect SLA commitments with real-time floor balancing. I'd be glad to take any questions and discuss next steps.</a:t>
+            </a:r>
+          </a:p>
+        </p:txBody>
+      </p:sp>
+      <p:sp>
+        <p:nvSpPr>
+          <p:cNvPr id="4" name="Slide Number Placeholder 3"/>
+          <p:cNvSpPr>
+            <a:spLocks noGrp="1"/>
+          </p:cNvSpPr>
+          <p:nvPr>
+            <p:ph type="sldNum" idx="5" sz="quarter"/>
+          </p:nvPr>
+        </p:nvSpPr>
+        <p:spPr/>
+      </p:sp>
+    </p:spTree>
+  </p:cSld>
+  <p:clrMapOvr>
+    <a:masterClrMapping/>
+  </p:clrMapOvr>
+</p:notes>
+</file>
+
 <file path=ppt/slideLayouts/slideLayout1.xml><?xml version="1.0" encoding="utf-8"?>
 <p:sldLayout xmlns:a="http://schemas.openxmlformats.org/drawingml/2006/main" xmlns:r="http://schemas.openxmlformats.org/officeDocument/2006/relationships" xmlns:p="http://schemas.openxmlformats.org/presentationml/2006/main" preserve="1">
   <p:cSld name="DEFAULT">
@@ -3186,6 +3262,532 @@
               <a:t>Reduces queue wait times (ASA) by 15–25% and curbs call abandonment during critical call volume peaks.</a:t>
             </a:r>
             <a:endParaRPr lang="en-US" sz="1400" dirty="0"/>
+          </a:p>
+        </p:txBody>
+      </p:sp>
+    </p:spTree>
+  </p:cSld>
+  <p:clrMapOvr>
+    <a:masterClrMapping/>
+  </p:clrMapOvr>
+</p:sld>
+</file>
+
+<file path=ppt/slides/slide4.xml><?xml version="1.0" encoding="utf-8"?>
+<p:sld xmlns:a="http://schemas.openxmlformats.org/drawingml/2006/main" xmlns:p="http://schemas.openxmlformats.org/presentationml/2006/main" xmlns:r="http://schemas.openxmlformats.org/officeDocument/2006/relationships">
+  <p:cSld>
+    <p:spTree>
+      <p:nvGrpSpPr>
+        <p:cNvPr id="1" name=""/>
+        <p:cNvGrpSpPr/>
+        <p:nvPr/>
+      </p:nvGrpSpPr>
+      <p:grpSpPr/>
+      <p:sp>
+        <p:nvSpPr>
+          <p:cNvPr id="2" name="Title 1"/>
+          <p:cNvSpPr>
+            <a:spLocks noGrp="1"/>
+          </p:cNvSpPr>
+          <p:nvPr>
+            <p:ph type="title" idx="100"/>
+          </p:nvPr>
+        </p:nvSpPr>
+        <p:spPr/>
+        <p:txBody>
+          <a:bodyPr/>
+          <a:lstStyle/>
+          <a:p/>
+        </p:txBody>
+      </p:sp>
+      <p:sp>
+        <p:nvSpPr>
+          <p:cNvPr id="3" name="Oval 2"/>
+          <p:cNvSpPr/>
+          <p:nvPr/>
+        </p:nvSpPr>
+        <p:spPr>
+          <a:xfrm>
+            <a:off x="8001000" y="365760"/>
+            <a:ext cx="365760" cy="365760"/>
+          </a:xfrm>
+          <a:prstGeom prst="ellipse">
+            <a:avLst/>
+          </a:prstGeom>
+          <a:solidFill>
+            <a:schemeClr val="accent2"/>
+          </a:solidFill>
+          <a:ln>
+            <a:noFill/>
+          </a:ln>
+        </p:spPr>
+        <p:style>
+          <a:lnRef idx="1">
+            <a:schemeClr val="accent1"/>
+          </a:lnRef>
+          <a:fillRef idx="3">
+            <a:schemeClr val="accent1"/>
+          </a:fillRef>
+          <a:effectRef idx="2">
+            <a:schemeClr val="accent1"/>
+          </a:effectRef>
+          <a:fontRef idx="minor">
+            <a:schemeClr val="lt1"/>
+          </a:fontRef>
+        </p:style>
+        <p:txBody>
+          <a:bodyPr rtlCol="0" anchor="ctr"/>
+          <a:lstStyle/>
+          <a:p>
+            <a:pPr algn="ctr"/>
+          </a:p>
+        </p:txBody>
+      </p:sp>
+      <p:sp>
+        <p:nvSpPr>
+          <p:cNvPr id="4" name="Oval 3"/>
+          <p:cNvSpPr/>
+          <p:nvPr/>
+        </p:nvSpPr>
+        <p:spPr>
+          <a:xfrm>
+            <a:off x="8211312" y="365760"/>
+            <a:ext cx="365760" cy="365760"/>
+          </a:xfrm>
+          <a:prstGeom prst="ellipse">
+            <a:avLst/>
+          </a:prstGeom>
+          <a:solidFill>
+            <a:schemeClr val="accent1"/>
+          </a:solidFill>
+          <a:ln>
+            <a:noFill/>
+          </a:ln>
+        </p:spPr>
+        <p:style>
+          <a:lnRef idx="1">
+            <a:schemeClr val="accent1"/>
+          </a:lnRef>
+          <a:fillRef idx="3">
+            <a:schemeClr val="accent1"/>
+          </a:fillRef>
+          <a:effectRef idx="2">
+            <a:schemeClr val="accent1"/>
+          </a:effectRef>
+          <a:fontRef idx="minor">
+            <a:schemeClr val="lt1"/>
+          </a:fontRef>
+        </p:style>
+        <p:txBody>
+          <a:bodyPr rtlCol="0" anchor="ctr"/>
+          <a:lstStyle/>
+          <a:p>
+            <a:pPr algn="ctr"/>
+          </a:p>
+        </p:txBody>
+      </p:sp>
+      <p:sp>
+        <p:nvSpPr>
+          <p:cNvPr id="5" name="TextBox 4"/>
+          <p:cNvSpPr txBox="1"/>
+          <p:nvPr/>
+        </p:nvSpPr>
+        <p:spPr>
+          <a:xfrm>
+            <a:off x="548640" y="320040"/>
+            <a:ext cx="6400800" cy="274320"/>
+          </a:xfrm>
+          <a:prstGeom prst="rect">
+            <a:avLst/>
+          </a:prstGeom>
+          <a:noFill/>
+        </p:spPr>
+        <p:txBody>
+          <a:bodyPr wrap="none">
+            <a:spAutoFit/>
+          </a:bodyPr>
+          <a:lstStyle/>
+          <a:p>
+            <a:r>
+              <a:rPr sz="1200" b="1">
+                <a:solidFill>
+                  <a:schemeClr val="tx1"/>
+                </a:solidFill>
+              </a:rPr>
+              <a:t>04 · CONCLUSION</a:t>
+            </a:r>
+          </a:p>
+        </p:txBody>
+      </p:sp>
+      <p:sp>
+        <p:nvSpPr>
+          <p:cNvPr id="6" name="TextBox 5"/>
+          <p:cNvSpPr txBox="1"/>
+          <p:nvPr/>
+        </p:nvSpPr>
+        <p:spPr>
+          <a:xfrm>
+            <a:off x="548640" y="640080"/>
+            <a:ext cx="8046720" cy="731520"/>
+          </a:xfrm>
+          <a:prstGeom prst="rect">
+            <a:avLst/>
+          </a:prstGeom>
+          <a:noFill/>
+        </p:spPr>
+        <p:txBody>
+          <a:bodyPr wrap="none">
+            <a:spAutoFit/>
+          </a:bodyPr>
+          <a:lstStyle/>
+          <a:p>
+            <a:pPr>
+              <a:defRPr sz="3600" b="1">
+                <a:solidFill>
+                  <a:schemeClr val="tx1"/>
+                </a:solidFill>
+              </a:defRPr>
+            </a:pPr>
+            <a:r>
+              <a:t>Thank You</a:t>
+            </a:r>
+          </a:p>
+          <a:p>
+            <a:pPr>
+              <a:spcBef>
+                <a:spcPts val="400"/>
+              </a:spcBef>
+            </a:pPr>
+            <a:r>
+              <a:rPr b="1" sz="1400">
+                <a:solidFill>
+                  <a:schemeClr val="tx1"/>
+                </a:solidFill>
+              </a:rPr>
+              <a:t>ZEL</a:t>
+            </a:r>
+            <a:r>
+              <a:rPr sz="1400">
+                <a:solidFill>
+                  <a:schemeClr val="tx1"/>
+                </a:solidFill>
+              </a:rPr>
+              <a:t> — </a:t>
+            </a:r>
+            <a:r>
+              <a:rPr i="1" sz="1300">
+                <a:solidFill>
+                  <a:schemeClr val="tx1"/>
+                </a:solidFill>
+              </a:rPr>
+              <a:t>"Zero wait to pause, Zero lag to serve"</a:t>
+            </a:r>
+          </a:p>
+        </p:txBody>
+      </p:sp>
+      <p:sp>
+        <p:nvSpPr>
+          <p:cNvPr id="7" name="Rounded Rectangle 6"/>
+          <p:cNvSpPr/>
+          <p:nvPr/>
+        </p:nvSpPr>
+        <p:spPr>
+          <a:xfrm>
+            <a:off x="548640" y="1463040"/>
+            <a:ext cx="8046720" cy="3200400"/>
+          </a:xfrm>
+          <a:prstGeom prst="roundRect">
+            <a:avLst/>
+          </a:prstGeom>
+          <a:solidFill>
+            <a:schemeClr val="bg1"/>
+          </a:solidFill>
+          <a:ln w="19050">
+            <a:solidFill>
+              <a:schemeClr val="accent1"/>
+            </a:solidFill>
+          </a:ln>
+        </p:spPr>
+        <p:style>
+          <a:lnRef idx="1">
+            <a:schemeClr val="accent1"/>
+          </a:lnRef>
+          <a:fillRef idx="3">
+            <a:schemeClr val="accent1"/>
+          </a:fillRef>
+          <a:effectRef idx="2">
+            <a:schemeClr val="accent1"/>
+          </a:effectRef>
+          <a:fontRef idx="minor">
+            <a:schemeClr val="lt1"/>
+          </a:fontRef>
+        </p:style>
+        <p:txBody>
+          <a:bodyPr rtlCol="0" anchor="ctr"/>
+          <a:lstStyle/>
+          <a:p>
+            <a:pPr algn="ctr"/>
+          </a:p>
+        </p:txBody>
+      </p:sp>
+      <p:sp>
+        <p:nvSpPr>
+          <p:cNvPr id="8" name="TextBox 7"/>
+          <p:cNvSpPr txBox="1"/>
+          <p:nvPr/>
+        </p:nvSpPr>
+        <p:spPr>
+          <a:xfrm>
+            <a:off x="822960" y="1691640"/>
+            <a:ext cx="3840480" cy="2743200"/>
+          </a:xfrm>
+          <a:prstGeom prst="rect">
+            <a:avLst/>
+          </a:prstGeom>
+          <a:noFill/>
+        </p:spPr>
+        <p:txBody>
+          <a:bodyPr wrap="square">
+            <a:spAutoFit/>
+          </a:bodyPr>
+          <a:lstStyle/>
+          <a:p>
+            <a:pPr>
+              <a:defRPr sz="1600" b="1">
+                <a:solidFill>
+                  <a:schemeClr val="tx1"/>
+                </a:solidFill>
+              </a:defRPr>
+            </a:pPr>
+            <a:r>
+              <a:t>Autonomous Floor Operations</a:t>
+            </a:r>
+          </a:p>
+          <a:p>
+            <a:pPr>
+              <a:spcBef>
+                <a:spcPts val="800"/>
+              </a:spcBef>
+              <a:defRPr sz="1100">
+                <a:solidFill>
+                  <a:schemeClr val="tx2"/>
+                </a:solidFill>
+              </a:defRPr>
+            </a:pPr>
+            <a:r>
+              <a:t>ZEL transforms contact center break management from manual chat delays into instant, algorithmic workforce flow.</a:t>
+            </a:r>
+          </a:p>
+          <a:p>
+            <a:pPr>
+              <a:spcBef>
+                <a:spcPts val="600"/>
+              </a:spcBef>
+            </a:pPr>
+            <a:r>
+              <a:rPr b="1" sz="1050">
+                <a:solidFill>
+                  <a:schemeClr val="tx1"/>
+                </a:solidFill>
+              </a:rPr>
+              <a:t>• Instant AUX Approvals: </a:t>
+            </a:r>
+            <a:r>
+              <a:rPr sz="1050">
+                <a:solidFill>
+                  <a:schemeClr val="tx2"/>
+                </a:solidFill>
+              </a:rPr>
+              <a:t>Sub-second Erlang-C staffing evaluation.</a:t>
+            </a:r>
+          </a:p>
+          <a:p>
+            <a:pPr>
+              <a:spcBef>
+                <a:spcPts val="600"/>
+              </a:spcBef>
+            </a:pPr>
+            <a:r>
+              <a:rPr b="1" sz="1050">
+                <a:solidFill>
+                  <a:schemeClr val="tx1"/>
+                </a:solidFill>
+              </a:rPr>
+              <a:t>• Autonomous ACW: </a:t>
+            </a:r>
+            <a:r>
+              <a:rPr sz="1050">
+                <a:solidFill>
+                  <a:schemeClr val="tx2"/>
+                </a:solidFill>
+              </a:rPr>
+              <a:t>AI summary generation &amp; direct CRM sync.</a:t>
+            </a:r>
+          </a:p>
+          <a:p>
+            <a:pPr>
+              <a:spcBef>
+                <a:spcPts val="600"/>
+              </a:spcBef>
+            </a:pPr>
+            <a:r>
+              <a:rPr b="1" sz="1050">
+                <a:solidFill>
+                  <a:schemeClr val="tx1"/>
+                </a:solidFill>
+              </a:rPr>
+              <a:t>• Dynamic Floor Flex: </a:t>
+            </a:r>
+            <a:r>
+              <a:rPr sz="1050">
+                <a:solidFill>
+                  <a:schemeClr val="tx2"/>
+                </a:solidFill>
+              </a:rPr>
+              <a:t>1-click intraday queue rebalancing.</a:t>
+            </a:r>
+          </a:p>
+        </p:txBody>
+      </p:sp>
+      <p:sp>
+        <p:nvSpPr>
+          <p:cNvPr id="9" name="TextBox 8"/>
+          <p:cNvSpPr txBox="1"/>
+          <p:nvPr/>
+        </p:nvSpPr>
+        <p:spPr>
+          <a:xfrm>
+            <a:off x="4846320" y="1691640"/>
+            <a:ext cx="3474720" cy="2743200"/>
+          </a:xfrm>
+          <a:prstGeom prst="rect">
+            <a:avLst/>
+          </a:prstGeom>
+          <a:noFill/>
+        </p:spPr>
+        <p:txBody>
+          <a:bodyPr wrap="square">
+            <a:spAutoFit/>
+          </a:bodyPr>
+          <a:lstStyle/>
+          <a:p>
+            <a:pPr>
+              <a:defRPr sz="1600" b="1">
+                <a:solidFill>
+                  <a:schemeClr val="tx1"/>
+                </a:solidFill>
+              </a:defRPr>
+            </a:pPr>
+            <a:r>
+              <a:t>Business Outcomes Delivered</a:t>
+            </a:r>
+          </a:p>
+          <a:p>
+            <a:pPr>
+              <a:spcBef>
+                <a:spcPts val="500"/>
+              </a:spcBef>
+            </a:pPr>
+            <a:r>
+              <a:rPr b="1" sz="1050">
+                <a:solidFill>
+                  <a:schemeClr val="accent1"/>
+                </a:solidFill>
+              </a:rPr>
+              <a:t>• 15–20 min: </a:t>
+            </a:r>
+            <a:r>
+              <a:rPr sz="1050">
+                <a:solidFill>
+                  <a:schemeClr val="tx2"/>
+                </a:solidFill>
+              </a:rPr>
+              <a:t>Productive shift time recovered per agent daily</a:t>
+            </a:r>
+          </a:p>
+          <a:p>
+            <a:pPr>
+              <a:spcBef>
+                <a:spcPts val="500"/>
+              </a:spcBef>
+            </a:pPr>
+            <a:r>
+              <a:rPr b="1" sz="1050">
+                <a:solidFill>
+                  <a:schemeClr val="accent1"/>
+                </a:solidFill>
+              </a:rPr>
+              <a:t>• 2 hrs: </a:t>
+            </a:r>
+            <a:r>
+              <a:rPr sz="1050">
+                <a:solidFill>
+                  <a:schemeClr val="tx2"/>
+                </a:solidFill>
+              </a:rPr>
+              <a:t>Supervisor capacity reclaimed per shift</a:t>
+            </a:r>
+          </a:p>
+          <a:p>
+            <a:pPr>
+              <a:spcBef>
+                <a:spcPts val="500"/>
+              </a:spcBef>
+            </a:pPr>
+            <a:r>
+              <a:rPr b="1" sz="1050">
+                <a:solidFill>
+                  <a:schemeClr val="accent1"/>
+                </a:solidFill>
+              </a:rPr>
+              <a:t>• 100%: </a:t>
+            </a:r>
+            <a:r>
+              <a:rPr sz="1050">
+                <a:solidFill>
+                  <a:schemeClr val="tx2"/>
+                </a:solidFill>
+              </a:rPr>
+              <a:t>Real-time floor visibility &amp; zero overtime costs</a:t>
+            </a:r>
+          </a:p>
+          <a:p>
+            <a:pPr>
+              <a:spcBef>
+                <a:spcPts val="500"/>
+              </a:spcBef>
+            </a:pPr>
+            <a:r>
+              <a:rPr b="1" sz="1050">
+                <a:solidFill>
+                  <a:schemeClr val="accent1"/>
+                </a:solidFill>
+              </a:rPr>
+              <a:t>• 15–25%: </a:t>
+            </a:r>
+            <a:r>
+              <a:rPr sz="1050">
+                <a:solidFill>
+                  <a:schemeClr val="tx2"/>
+                </a:solidFill>
+              </a:rPr>
+              <a:t>Lower queue wait times during volume surges</a:t>
+            </a:r>
+          </a:p>
+          <a:p>
+            <a:pPr>
+              <a:spcBef>
+                <a:spcPts val="1400"/>
+              </a:spcBef>
+            </a:pPr>
+            <a:r>
+              <a:rPr b="1" sz="1400">
+                <a:solidFill>
+                  <a:schemeClr val="accent2"/>
+                </a:solidFill>
+              </a:rPr>
+              <a:t>Questions &amp; Discussion</a:t>
+            </a:r>
           </a:p>
         </p:txBody>
       </p:sp>

</xml_diff>

<commit_message>
Add official Panda face app icon to Slide 1 header and Slide 4 Thank You slide
</commit_message>
<xml_diff>
--- a/AUX_Break_Management.pptx
+++ b/AUX_Break_Management.pptx
@@ -1300,8 +1300,8 @@
         </p:nvSpPr>
         <p:spPr>
           <a:xfrm>
-            <a:off x="548640" y="640080"/>
-            <a:ext cx="8046720" cy="731520"/>
+            <a:off x="548640" y="620000"/>
+            <a:ext cx="8046720" cy="420000"/>
           </a:xfrm>
           <a:prstGeom prst="rect">
             <a:avLst/>
@@ -1321,25 +1321,6 @@
               <a:t>Problem Statement</a:t>
             </a:r>
             <a:endParaRPr lang="en-US" sz="3600" dirty="0"/>
-          </a:p>
-          <a:p>
-            <a:pPr>
-              <a:spcBef>
-                <a:spcPts val="400"/>
-              </a:spcBef>
-            </a:pPr>
-            <a:r>
-              <a:rPr b="1" sz="1400"/>
-              <a:t>ZEL</a:t>
-            </a:r>
-            <a:r>
-              <a:rPr sz="1400"/>
-              <a:t> — </a:t>
-            </a:r>
-            <a:r>
-              <a:rPr i="1" sz="1300"/>
-              <a:t>"Zero wait to pause, Zero lag to serve"</a:t>
-            </a:r>
           </a:p>
         </p:txBody>
       </p:sp>
@@ -1796,6 +1777,79 @@
               <a:t>End Customers</a:t>
             </a:r>
             <a:endParaRPr lang="en-US" sz="1600" dirty="0"/>
+          </a:p>
+        </p:txBody>
+      </p:sp>
+      <p:pic>
+        <p:nvPicPr>
+          <p:cNvPr id="23" name="Picture 22" descr="favicon.png"/>
+          <p:cNvPicPr>
+            <a:picLocks noChangeAspect="1"/>
+          </p:cNvPicPr>
+          <p:nvPr/>
+        </p:nvPicPr>
+        <p:blipFill>
+          <a:blip r:embed="rId7"/>
+          <a:stretch>
+            <a:fillRect/>
+          </a:stretch>
+        </p:blipFill>
+        <p:spPr>
+          <a:xfrm>
+            <a:off x="548640" y="1070000"/>
+            <a:ext cx="320000" cy="320000"/>
+          </a:xfrm>
+          <a:prstGeom prst="rect">
+            <a:avLst/>
+          </a:prstGeom>
+        </p:spPr>
+      </p:pic>
+      <p:sp>
+        <p:nvSpPr>
+          <p:cNvPr id="24" name="TextBox 23"/>
+          <p:cNvSpPr txBox="1"/>
+          <p:nvPr/>
+        </p:nvSpPr>
+        <p:spPr>
+          <a:xfrm>
+            <a:off x="920000" y="1050000"/>
+            <a:ext cx="6800000" cy="340000"/>
+          </a:xfrm>
+          <a:prstGeom prst="rect">
+            <a:avLst/>
+          </a:prstGeom>
+          <a:noFill/>
+        </p:spPr>
+        <p:txBody>
+          <a:bodyPr wrap="square" lIns="0" tIns="0" rIns="0" bIns="0">
+            <a:spAutoFit/>
+          </a:bodyPr>
+          <a:lstStyle/>
+          <a:p>
+            <a:r>
+              <a:rPr b="1" sz="1400">
+                <a:solidFill>
+                  <a:schemeClr val="tx1"/>
+                </a:solidFill>
+              </a:rPr>
+              <a:t>ZEL</a:t>
+            </a:r>
+            <a:r>
+              <a:rPr sz="1400">
+                <a:solidFill>
+                  <a:schemeClr val="tx1"/>
+                </a:solidFill>
+              </a:rPr>
+              <a:t> — </a:t>
+            </a:r>
+            <a:r>
+              <a:rPr i="1" sz="1300">
+                <a:solidFill>
+                  <a:schemeClr val="tx1"/>
+                </a:solidFill>
+              </a:rPr>
+              <a:t>"Zero wait to pause, Zero lag to serve"</a:t>
+            </a:r>
           </a:p>
         </p:txBody>
       </p:sp>
@@ -3285,24 +3339,7 @@
       <p:grpSpPr/>
       <p:sp>
         <p:nvSpPr>
-          <p:cNvPr id="2" name="Title 1"/>
-          <p:cNvSpPr>
-            <a:spLocks noGrp="1"/>
-          </p:cNvSpPr>
-          <p:nvPr>
-            <p:ph type="title" idx="100"/>
-          </p:nvPr>
-        </p:nvSpPr>
-        <p:spPr/>
-        <p:txBody>
-          <a:bodyPr/>
-          <a:lstStyle/>
-          <a:p/>
-        </p:txBody>
-      </p:sp>
-      <p:sp>
-        <p:nvSpPr>
-          <p:cNvPr id="3" name="Oval 2"/>
+          <p:cNvPr id="2" name="Oval 1"/>
           <p:cNvSpPr/>
           <p:nvPr/>
         </p:nvSpPr>
@@ -3345,7 +3382,7 @@
       </p:sp>
       <p:sp>
         <p:nvSpPr>
-          <p:cNvPr id="4" name="Oval 3"/>
+          <p:cNvPr id="3" name="Oval 2"/>
           <p:cNvSpPr/>
           <p:nvPr/>
         </p:nvSpPr>
@@ -3388,13 +3425,13 @@
       </p:sp>
       <p:sp>
         <p:nvSpPr>
-          <p:cNvPr id="5" name="TextBox 4"/>
+          <p:cNvPr id="4" name="TextBox 3"/>
           <p:cNvSpPr txBox="1"/>
           <p:nvPr/>
         </p:nvSpPr>
         <p:spPr>
           <a:xfrm>
-            <a:off x="548640" y="320040"/>
+            <a:off x="548640" y="300040"/>
             <a:ext cx="6400800" cy="274320"/>
           </a:xfrm>
           <a:prstGeom prst="rect">
@@ -3403,7 +3440,7 @@
           <a:noFill/>
         </p:spPr>
         <p:txBody>
-          <a:bodyPr wrap="none">
+          <a:bodyPr wrap="none" lIns="0" tIns="0" rIns="0" bIns="0">
             <a:spAutoFit/>
           </a:bodyPr>
           <a:lstStyle/>
@@ -3421,88 +3458,22 @@
       </p:sp>
       <p:sp>
         <p:nvSpPr>
-          <p:cNvPr id="6" name="TextBox 5"/>
-          <p:cNvSpPr txBox="1"/>
-          <p:nvPr/>
-        </p:nvSpPr>
-        <p:spPr>
-          <a:xfrm>
-            <a:off x="548640" y="640080"/>
-            <a:ext cx="8046720" cy="731520"/>
-          </a:xfrm>
-          <a:prstGeom prst="rect">
-            <a:avLst/>
-          </a:prstGeom>
-          <a:noFill/>
-        </p:spPr>
-        <p:txBody>
-          <a:bodyPr wrap="none">
-            <a:spAutoFit/>
-          </a:bodyPr>
-          <a:lstStyle/>
-          <a:p>
-            <a:pPr>
-              <a:defRPr sz="3600" b="1">
-                <a:solidFill>
-                  <a:schemeClr val="tx1"/>
-                </a:solidFill>
-              </a:defRPr>
-            </a:pPr>
-            <a:r>
-              <a:t>Thank You</a:t>
-            </a:r>
-          </a:p>
-          <a:p>
-            <a:pPr>
-              <a:spcBef>
-                <a:spcPts val="400"/>
-              </a:spcBef>
-            </a:pPr>
-            <a:r>
-              <a:rPr b="1" sz="1400">
-                <a:solidFill>
-                  <a:schemeClr val="tx1"/>
-                </a:solidFill>
-              </a:rPr>
-              <a:t>ZEL</a:t>
-            </a:r>
-            <a:r>
-              <a:rPr sz="1400">
-                <a:solidFill>
-                  <a:schemeClr val="tx1"/>
-                </a:solidFill>
-              </a:rPr>
-              <a:t> — </a:t>
-            </a:r>
-            <a:r>
-              <a:rPr i="1" sz="1300">
-                <a:solidFill>
-                  <a:schemeClr val="tx1"/>
-                </a:solidFill>
-              </a:rPr>
-              <a:t>"Zero wait to pause, Zero lag to serve"</a:t>
-            </a:r>
-          </a:p>
-        </p:txBody>
-      </p:sp>
-      <p:sp>
-        <p:nvSpPr>
-          <p:cNvPr id="7" name="Rounded Rectangle 6"/>
+          <p:cNvPr id="5" name="Oval 4"/>
           <p:cNvSpPr/>
           <p:nvPr/>
         </p:nvSpPr>
         <p:spPr>
           <a:xfrm>
-            <a:off x="548640" y="1463040"/>
-            <a:ext cx="8046720" cy="3200400"/>
-          </a:xfrm>
-          <a:prstGeom prst="roundRect">
+            <a:off x="548640" y="560000"/>
+            <a:ext cx="680000" cy="680000"/>
+          </a:xfrm>
+          <a:prstGeom prst="ellipse">
             <a:avLst/>
           </a:prstGeom>
           <a:solidFill>
             <a:schemeClr val="bg1"/>
           </a:solidFill>
-          <a:ln w="19050">
+          <a:ln w="25400">
             <a:solidFill>
               <a:schemeClr val="accent1"/>
             </a:solidFill>
@@ -3530,9 +3501,144 @@
           </a:p>
         </p:txBody>
       </p:sp>
-      <p:sp>
-        <p:nvSpPr>
-          <p:cNvPr id="8" name="TextBox 7"/>
+      <p:pic>
+        <p:nvPicPr>
+          <p:cNvPr id="6" name="Picture 5" descr="favicon.png"/>
+          <p:cNvPicPr>
+            <a:picLocks noChangeAspect="1"/>
+          </p:cNvPicPr>
+          <p:nvPr/>
+        </p:nvPicPr>
+        <p:blipFill>
+          <a:blip r:embed="rId2"/>
+          <a:stretch>
+            <a:fillRect/>
+          </a:stretch>
+        </p:blipFill>
+        <p:spPr>
+          <a:xfrm>
+            <a:off x="588640" y="600000"/>
+            <a:ext cx="600000" cy="600000"/>
+          </a:xfrm>
+          <a:prstGeom prst="rect">
+            <a:avLst/>
+          </a:prstGeom>
+        </p:spPr>
+      </p:pic>
+      <p:sp>
+        <p:nvSpPr>
+          <p:cNvPr id="7" name="TextBox 6"/>
+          <p:cNvSpPr txBox="1"/>
+          <p:nvPr/>
+        </p:nvSpPr>
+        <p:spPr>
+          <a:xfrm>
+            <a:off x="1340000" y="540000"/>
+            <a:ext cx="6500000" cy="780000"/>
+          </a:xfrm>
+          <a:prstGeom prst="rect">
+            <a:avLst/>
+          </a:prstGeom>
+          <a:noFill/>
+        </p:spPr>
+        <p:txBody>
+          <a:bodyPr wrap="square" lIns="0" tIns="0" rIns="0" bIns="0">
+            <a:spAutoFit/>
+          </a:bodyPr>
+          <a:lstStyle/>
+          <a:p>
+            <a:pPr>
+              <a:defRPr sz="3200" b="1">
+                <a:solidFill>
+                  <a:schemeClr val="tx1"/>
+                </a:solidFill>
+              </a:defRPr>
+            </a:pPr>
+            <a:r>
+              <a:t>Thank You</a:t>
+            </a:r>
+          </a:p>
+          <a:p>
+            <a:pPr>
+              <a:spcBef>
+                <a:spcPts val="300"/>
+              </a:spcBef>
+            </a:pPr>
+            <a:r>
+              <a:rPr b="1" sz="1350">
+                <a:solidFill>
+                  <a:schemeClr val="tx1"/>
+                </a:solidFill>
+              </a:rPr>
+              <a:t>ZEL</a:t>
+            </a:r>
+            <a:r>
+              <a:rPr sz="1350">
+                <a:solidFill>
+                  <a:schemeClr val="tx1"/>
+                </a:solidFill>
+              </a:rPr>
+              <a:t> — </a:t>
+            </a:r>
+            <a:r>
+              <a:rPr i="1" sz="1300">
+                <a:solidFill>
+                  <a:schemeClr val="tx1"/>
+                </a:solidFill>
+              </a:rPr>
+              <a:t>"Zero wait to pause, Zero lag to serve"</a:t>
+            </a:r>
+          </a:p>
+        </p:txBody>
+      </p:sp>
+      <p:sp>
+        <p:nvSpPr>
+          <p:cNvPr id="8" name="Rounded Rectangle 7"/>
+          <p:cNvSpPr/>
+          <p:nvPr/>
+        </p:nvSpPr>
+        <p:spPr>
+          <a:xfrm>
+            <a:off x="548640" y="1463040"/>
+            <a:ext cx="8046720" cy="3200400"/>
+          </a:xfrm>
+          <a:prstGeom prst="roundRect">
+            <a:avLst/>
+          </a:prstGeom>
+          <a:solidFill>
+            <a:schemeClr val="bg1"/>
+          </a:solidFill>
+          <a:ln w="19050">
+            <a:solidFill>
+              <a:schemeClr val="accent1"/>
+            </a:solidFill>
+          </a:ln>
+        </p:spPr>
+        <p:style>
+          <a:lnRef idx="1">
+            <a:schemeClr val="accent1"/>
+          </a:lnRef>
+          <a:fillRef idx="3">
+            <a:schemeClr val="accent1"/>
+          </a:fillRef>
+          <a:effectRef idx="2">
+            <a:schemeClr val="accent1"/>
+          </a:effectRef>
+          <a:fontRef idx="minor">
+            <a:schemeClr val="lt1"/>
+          </a:fontRef>
+        </p:style>
+        <p:txBody>
+          <a:bodyPr rtlCol="0" anchor="ctr"/>
+          <a:lstStyle/>
+          <a:p>
+            <a:pPr algn="ctr"/>
+          </a:p>
+        </p:txBody>
+      </p:sp>
+      <p:sp>
+        <p:nvSpPr>
+          <p:cNvPr id="9" name="TextBox 8"/>
           <p:cNvSpPr txBox="1"/>
           <p:nvPr/>
         </p:nvSpPr>
@@ -3651,7 +3757,7 @@
       </p:sp>
       <p:sp>
         <p:nvSpPr>
-          <p:cNvPr id="9" name="TextBox 8"/>
+          <p:cNvPr id="10" name="TextBox 9"/>
           <p:cNvSpPr txBox="1"/>
           <p:nvPr/>
         </p:nvSpPr>

</xml_diff>